<commit_message>
0806 검정색보단 #111 181818
</commit_message>
<xml_diff>
--- a/0_wbs/도서검색웹_SB_2026_0805.pptx
+++ b/0_wbs/도서검색웹_SB_2026_0805.pptx
@@ -237,7 +237,7 @@
           <a:p>
             <a:fld id="{999972AA-FE3A-41E8-94D7-0A348C1614D1}" type="datetimeFigureOut">
               <a:rPr lang="ko-KR" altLang="en-US" smtClean="0"/>
-              <a:t>2026-08-05</a:t>
+              <a:t>2026-08-06</a:t>
             </a:fld>
             <a:endParaRPr lang="ko-KR" altLang="en-US"/>
           </a:p>
@@ -402,7 +402,7 @@
           <a:p>
             <a:fld id="{CB25E66B-2806-4CC0-B543-C1F698B8CB0C}" type="datetimeFigureOut">
               <a:rPr lang="ko-KR" altLang="en-US" smtClean="0"/>
-              <a:t>2026-08-05</a:t>
+              <a:t>2026-08-06</a:t>
             </a:fld>
             <a:endParaRPr lang="ko-KR" altLang="en-US"/>
           </a:p>
@@ -12401,7 +12401,7 @@
           <p:nvPr>
             <p:extLst>
               <p:ext uri="{D42A27DB-BD31-4B8C-83A1-F6EECF244321}">
-                <p14:modId xmlns:p14="http://schemas.microsoft.com/office/powerpoint/2010/main" val="1274650770"/>
+                <p14:modId xmlns:p14="http://schemas.microsoft.com/office/powerpoint/2010/main" val="2275993006"/>
               </p:ext>
             </p:extLst>
           </p:nvPr>
@@ -14993,17 +14993,47 @@
                         <a:buChar char="•"/>
                       </a:pPr>
                       <a:r>
-                        <a:rPr lang="en-US" altLang="ko-KR" sz="800" dirty="0">
+                        <a:rPr lang="ko-KR" altLang="en-US" sz="800" baseline="0" dirty="0">
                           <a:solidFill>
                             <a:schemeClr val="tx1"/>
                           </a:solidFill>
                           <a:latin typeface="나눔고딕" panose="020D0604000000000000" pitchFamily="50" charset="-127"/>
                           <a:ea typeface="나눔고딕" panose="020D0604000000000000" pitchFamily="50" charset="-127"/>
                         </a:rPr>
-                        <a:t>PC/</a:t>
+                        <a:t>반응형 웹사이트</a:t>
                       </a:r>
                       <a:r>
-                        <a:rPr lang="ko-KR" altLang="en-US" sz="800" dirty="0" err="1">
+                        <a:rPr lang="en-US" altLang="ko-KR" sz="800" baseline="0" dirty="0">
+                          <a:solidFill>
+                            <a:schemeClr val="tx1"/>
+                          </a:solidFill>
+                          <a:latin typeface="나눔고딕" panose="020D0604000000000000" pitchFamily="50" charset="-127"/>
+                          <a:ea typeface="나눔고딕" panose="020D0604000000000000" pitchFamily="50" charset="-127"/>
+                        </a:rPr>
+                        <a:t>( PC, </a:t>
+                      </a:r>
+                      <a:r>
+                        <a:rPr lang="ko-KR" altLang="en-US" sz="800" baseline="0" dirty="0">
+                          <a:solidFill>
+                            <a:schemeClr val="tx1"/>
+                          </a:solidFill>
+                          <a:latin typeface="나눔고딕" panose="020D0604000000000000" pitchFamily="50" charset="-127"/>
+                          <a:ea typeface="나눔고딕" panose="020D0604000000000000" pitchFamily="50" charset="-127"/>
+                        </a:rPr>
+                        <a:t>태블릿</a:t>
+                      </a:r>
+                      <a:r>
+                        <a:rPr lang="en-US" altLang="ko-KR" sz="800" baseline="0" dirty="0">
+                          <a:solidFill>
+                            <a:schemeClr val="tx1"/>
+                          </a:solidFill>
+                          <a:latin typeface="나눔고딕" panose="020D0604000000000000" pitchFamily="50" charset="-127"/>
+                          <a:ea typeface="나눔고딕" panose="020D0604000000000000" pitchFamily="50" charset="-127"/>
+                        </a:rPr>
+                        <a:t>, </a:t>
+                      </a:r>
+                      <a:r>
+                        <a:rPr lang="ko-KR" altLang="en-US" sz="800" baseline="0" dirty="0">
                           <a:solidFill>
                             <a:schemeClr val="tx1"/>
                           </a:solidFill>
@@ -15020,25 +15050,8 @@
                           <a:latin typeface="나눔고딕" panose="020D0604000000000000" pitchFamily="50" charset="-127"/>
                           <a:ea typeface="나눔고딕" panose="020D0604000000000000" pitchFamily="50" charset="-127"/>
                         </a:rPr>
-                        <a:t> </a:t>
+                        <a:t>)</a:t>
                       </a:r>
-                      <a:r>
-                        <a:rPr lang="ko-KR" altLang="en-US" sz="800" baseline="0" dirty="0">
-                          <a:solidFill>
-                            <a:schemeClr val="tx1"/>
-                          </a:solidFill>
-                          <a:latin typeface="나눔고딕" panose="020D0604000000000000" pitchFamily="50" charset="-127"/>
-                          <a:ea typeface="나눔고딕" panose="020D0604000000000000" pitchFamily="50" charset="-127"/>
-                        </a:rPr>
-                        <a:t>웹</a:t>
-                      </a:r>
-                      <a:endParaRPr lang="en-US" altLang="ko-KR" sz="800" baseline="0" dirty="0">
-                        <a:solidFill>
-                          <a:schemeClr val="tx1"/>
-                        </a:solidFill>
-                        <a:latin typeface="나눔고딕" panose="020D0604000000000000" pitchFamily="50" charset="-127"/>
-                        <a:ea typeface="나눔고딕" panose="020D0604000000000000" pitchFamily="50" charset="-127"/>
-                      </a:endParaRPr>
                     </a:p>
                   </a:txBody>
                   <a:tcPr anchor="ctr">
@@ -15184,21 +15197,42 @@
                     <a:p>
                       <a:pPr algn="l" latinLnBrk="1"/>
                       <a:r>
+                        <a:rPr lang="ko-KR" altLang="en-US" sz="800" dirty="0"/>
+                        <a:t>특이사항</a:t>
+                      </a:r>
+                      <a:r>
                         <a:rPr lang="en-US" altLang="ko-KR" sz="800" dirty="0"/>
-                        <a:t>2026</a:t>
+                        <a:t>: ‘</a:t>
                       </a:r>
                       <a:r>
                         <a:rPr lang="ko-KR" altLang="en-US" sz="800" dirty="0"/>
-                        <a:t>년 </a:t>
+                        <a:t>초등 수능 수학 </a:t>
                       </a:r>
                       <a:r>
                         <a:rPr lang="en-US" altLang="ko-KR" sz="800" dirty="0"/>
-                        <a:t>8</a:t>
+                        <a:t>KICK’, ‘</a:t>
+                      </a:r>
+                      <a:r>
+                        <a:rPr lang="ko-KR" altLang="en-US" sz="800" dirty="0" err="1"/>
+                        <a:t>뭔말</a:t>
+                      </a:r>
+                      <a:r>
+                        <a:rPr lang="en-US" altLang="ko-KR" sz="800" dirty="0"/>
+                        <a:t> </a:t>
                       </a:r>
                       <a:r>
                         <a:rPr lang="ko-KR" altLang="en-US" sz="800" dirty="0"/>
-                        <a:t>월</a:t>
+                        <a:t>과학 용어</a:t>
                       </a:r>
+                      <a:r>
+                        <a:rPr lang="en-US" altLang="ko-KR" sz="800" dirty="0"/>
+                        <a:t>＇</a:t>
+                      </a:r>
+                      <a:r>
+                        <a:rPr lang="ko-KR" altLang="en-US" sz="800"/>
+                        <a:t>등 핵심 도서 시리즈 중심의 마케팅 전개</a:t>
+                      </a:r>
+                      <a:endParaRPr lang="ko-KR" altLang="en-US" sz="800" dirty="0"/>
                     </a:p>
                   </a:txBody>
                   <a:tcPr marL="68352" marR="68352" marT="34176" marB="34176" anchor="ctr">

</xml_diff>